<commit_message>
WIP: rework RA/Dec uncertainties from SIMBAD (half-finished)
</commit_message>
<xml_diff>
--- a/Overview_post_mt.pptx
+++ b/Overview_post_mt.pptx
@@ -107,6 +107,11 @@
       </a:defRPr>
     </a:lvl9pPr>
   </p:defaultTextStyle>
+  <p:extLst>
+    <p:ext uri="{EFAFB233-063F-42B5-8137-9DF3F51BA10A}">
+      <p15:sldGuideLst xmlns:p15="http://schemas.microsoft.com/office/powerpoint/2012/main"/>
+    </p:ext>
+  </p:extLst>
 </p:presentation>
 </file>
 
@@ -220,7 +225,7 @@
           <a:p>
             <a:fld id="{76CD2E81-2FF3-7645-81CE-9F2ADE8F5859}" type="datetimeFigureOut">
               <a:rPr lang="en-NL" smtClean="0"/>
-              <a:t>22/05/2026</a:t>
+              <a:t>04/06/2026</a:t>
             </a:fld>
             <a:endParaRPr lang="en-NL"/>
           </a:p>
@@ -721,7 +726,7 @@
           <a:p>
             <a:fld id="{E8104612-83DF-984F-B51C-C4D0AB0D78C6}" type="datetimeFigureOut">
               <a:rPr lang="en-NL" smtClean="0"/>
-              <a:t>22/05/2026</a:t>
+              <a:t>04/06/2026</a:t>
             </a:fld>
             <a:endParaRPr lang="en-NL"/>
           </a:p>
@@ -921,7 +926,7 @@
           <a:p>
             <a:fld id="{E8104612-83DF-984F-B51C-C4D0AB0D78C6}" type="datetimeFigureOut">
               <a:rPr lang="en-NL" smtClean="0"/>
-              <a:t>22/05/2026</a:t>
+              <a:t>04/06/2026</a:t>
             </a:fld>
             <a:endParaRPr lang="en-NL"/>
           </a:p>
@@ -1131,7 +1136,7 @@
           <a:p>
             <a:fld id="{E8104612-83DF-984F-B51C-C4D0AB0D78C6}" type="datetimeFigureOut">
               <a:rPr lang="en-NL" smtClean="0"/>
-              <a:t>22/05/2026</a:t>
+              <a:t>04/06/2026</a:t>
             </a:fld>
             <a:endParaRPr lang="en-NL"/>
           </a:p>
@@ -1331,7 +1336,7 @@
           <a:p>
             <a:fld id="{E8104612-83DF-984F-B51C-C4D0AB0D78C6}" type="datetimeFigureOut">
               <a:rPr lang="en-NL" smtClean="0"/>
-              <a:t>22/05/2026</a:t>
+              <a:t>04/06/2026</a:t>
             </a:fld>
             <a:endParaRPr lang="en-NL"/>
           </a:p>
@@ -1607,7 +1612,7 @@
           <a:p>
             <a:fld id="{E8104612-83DF-984F-B51C-C4D0AB0D78C6}" type="datetimeFigureOut">
               <a:rPr lang="en-NL" smtClean="0"/>
-              <a:t>22/05/2026</a:t>
+              <a:t>04/06/2026</a:t>
             </a:fld>
             <a:endParaRPr lang="en-NL"/>
           </a:p>
@@ -1875,7 +1880,7 @@
           <a:p>
             <a:fld id="{E8104612-83DF-984F-B51C-C4D0AB0D78C6}" type="datetimeFigureOut">
               <a:rPr lang="en-NL" smtClean="0"/>
-              <a:t>22/05/2026</a:t>
+              <a:t>04/06/2026</a:t>
             </a:fld>
             <a:endParaRPr lang="en-NL"/>
           </a:p>
@@ -2290,7 +2295,7 @@
           <a:p>
             <a:fld id="{E8104612-83DF-984F-B51C-C4D0AB0D78C6}" type="datetimeFigureOut">
               <a:rPr lang="en-NL" smtClean="0"/>
-              <a:t>22/05/2026</a:t>
+              <a:t>04/06/2026</a:t>
             </a:fld>
             <a:endParaRPr lang="en-NL"/>
           </a:p>
@@ -2432,7 +2437,7 @@
           <a:p>
             <a:fld id="{E8104612-83DF-984F-B51C-C4D0AB0D78C6}" type="datetimeFigureOut">
               <a:rPr lang="en-NL" smtClean="0"/>
-              <a:t>22/05/2026</a:t>
+              <a:t>04/06/2026</a:t>
             </a:fld>
             <a:endParaRPr lang="en-NL"/>
           </a:p>
@@ -2545,7 +2550,7 @@
           <a:p>
             <a:fld id="{E8104612-83DF-984F-B51C-C4D0AB0D78C6}" type="datetimeFigureOut">
               <a:rPr lang="en-NL" smtClean="0"/>
-              <a:t>22/05/2026</a:t>
+              <a:t>04/06/2026</a:t>
             </a:fld>
             <a:endParaRPr lang="en-NL"/>
           </a:p>
@@ -2858,7 +2863,7 @@
           <a:p>
             <a:fld id="{E8104612-83DF-984F-B51C-C4D0AB0D78C6}" type="datetimeFigureOut">
               <a:rPr lang="en-NL" smtClean="0"/>
-              <a:t>22/05/2026</a:t>
+              <a:t>04/06/2026</a:t>
             </a:fld>
             <a:endParaRPr lang="en-NL"/>
           </a:p>
@@ -3147,7 +3152,7 @@
           <a:p>
             <a:fld id="{E8104612-83DF-984F-B51C-C4D0AB0D78C6}" type="datetimeFigureOut">
               <a:rPr lang="en-NL" smtClean="0"/>
-              <a:t>22/05/2026</a:t>
+              <a:t>04/06/2026</a:t>
             </a:fld>
             <a:endParaRPr lang="en-NL"/>
           </a:p>
@@ -3390,7 +3395,7 @@
           <a:p>
             <a:fld id="{E8104612-83DF-984F-B51C-C4D0AB0D78C6}" type="datetimeFigureOut">
               <a:rPr lang="en-NL" smtClean="0"/>
-              <a:t>22/05/2026</a:t>
+              <a:t>04/06/2026</a:t>
             </a:fld>
             <a:endParaRPr lang="en-NL"/>
           </a:p>
@@ -3821,7 +3826,7 @@
         </p:nvGrpSpPr>
         <p:grpSpPr>
           <a:xfrm>
-            <a:off x="419851" y="449740"/>
+            <a:off x="385212" y="539312"/>
             <a:ext cx="11421575" cy="5390540"/>
             <a:chOff x="419851" y="449740"/>
             <a:chExt cx="11421575" cy="5390540"/>
@@ -4893,8 +4898,8 @@
               <a:chExt cx="677611" cy="1249417"/>
             </a:xfrm>
           </p:grpSpPr>
-          <mc:AlternateContent xmlns:mc="http://schemas.openxmlformats.org/markup-compatibility/2006">
-            <mc:Choice xmlns:p14="http://schemas.microsoft.com/office/powerpoint/2010/main" Requires="p14">
+          <mc:AlternateContent xmlns:mc="http://schemas.openxmlformats.org/markup-compatibility/2006" xmlns:p14="http://schemas.microsoft.com/office/powerpoint/2010/main">
+            <mc:Choice Requires="p14">
               <p:contentPart p14:bwMode="auto" r:id="rId3">
                 <p14:nvContentPartPr>
                   <p14:cNvPr id="87" name="Ink 86">
@@ -4913,7 +4918,7 @@
                 </p14:xfrm>
               </p:contentPart>
             </mc:Choice>
-            <mc:Fallback>
+            <mc:Fallback xmlns="">
               <p:pic>
                 <p:nvPicPr>
                   <p:cNvPr id="87" name="Ink 86">
@@ -5511,10 +5516,10 @@
           </p:nvGrpSpPr>
           <p:grpSpPr>
             <a:xfrm>
-              <a:off x="3819042" y="2554385"/>
-              <a:ext cx="766622" cy="1091616"/>
-              <a:chOff x="3582353" y="2577485"/>
-              <a:chExt cx="766622" cy="1091616"/>
+              <a:off x="3819042" y="2552593"/>
+              <a:ext cx="766016" cy="1093408"/>
+              <a:chOff x="3582353" y="2575693"/>
+              <a:chExt cx="766016" cy="1093408"/>
             </a:xfrm>
           </p:grpSpPr>
           <p:sp>
@@ -5660,18 +5665,18 @@
             </p:nvGrpSpPr>
             <p:grpSpPr>
               <a:xfrm>
-                <a:off x="4027174" y="2577485"/>
-                <a:ext cx="321801" cy="317899"/>
-                <a:chOff x="4031500" y="2460708"/>
+                <a:off x="4026567" y="2575693"/>
+                <a:ext cx="321802" cy="317900"/>
+                <a:chOff x="4030666" y="2458275"/>
                 <a:chExt cx="435368" cy="430089"/>
               </a:xfrm>
             </p:grpSpPr>
             <p:sp>
               <p:nvSpPr>
-                <p:cNvPr id="107" name="Oval 106">
+                <p:cNvPr id="108" name="Oval 107">
                   <a:extLst>
                     <a:ext uri="{FF2B5EF4-FFF2-40B4-BE49-F238E27FC236}">
-                      <a16:creationId xmlns:a16="http://schemas.microsoft.com/office/drawing/2014/main" id="{30E12CAF-4710-2776-9888-C336E7A19637}"/>
+                      <a16:creationId xmlns:a16="http://schemas.microsoft.com/office/drawing/2014/main" id="{29BD977D-5EFD-E683-C92C-996CD660E35E}"/>
                     </a:ext>
                   </a:extLst>
                 </p:cNvPr>
@@ -5680,29 +5685,17 @@
               </p:nvSpPr>
               <p:spPr>
                 <a:xfrm>
-                  <a:off x="4080791" y="2509401"/>
-                  <a:ext cx="336786" cy="332702"/>
+                  <a:off x="4030666" y="2458275"/>
+                  <a:ext cx="435368" cy="430089"/>
                 </a:xfrm>
                 <a:prstGeom prst="ellipse">
                   <a:avLst/>
                 </a:prstGeom>
-                <a:gradFill>
-                  <a:gsLst>
-                    <a:gs pos="88000">
-                      <a:srgbClr val="608DBC">
-                        <a:lumMod val="100000"/>
-                      </a:srgbClr>
-                    </a:gs>
-                    <a:gs pos="55000">
-                      <a:srgbClr val="83B7E8">
-                        <a:lumMod val="96000"/>
-                      </a:srgbClr>
-                    </a:gs>
-                  </a:gsLst>
-                  <a:path path="circle">
-                    <a:fillToRect l="50000" t="50000" r="50000" b="50000"/>
-                  </a:path>
-                </a:gradFill>
+                <a:solidFill>
+                  <a:srgbClr val="77B0E6">
+                    <a:alpha val="67000"/>
+                  </a:srgbClr>
+                </a:solidFill>
                 <a:ln>
                   <a:noFill/>
                 </a:ln>
@@ -5739,10 +5732,10 @@
             </p:sp>
             <p:sp>
               <p:nvSpPr>
-                <p:cNvPr id="108" name="Oval 107">
+                <p:cNvPr id="107" name="Oval 106">
                   <a:extLst>
                     <a:ext uri="{FF2B5EF4-FFF2-40B4-BE49-F238E27FC236}">
-                      <a16:creationId xmlns:a16="http://schemas.microsoft.com/office/drawing/2014/main" id="{29BD977D-5EFD-E683-C92C-996CD660E35E}"/>
+                      <a16:creationId xmlns:a16="http://schemas.microsoft.com/office/drawing/2014/main" id="{30E12CAF-4710-2776-9888-C336E7A19637}"/>
                     </a:ext>
                   </a:extLst>
                 </p:cNvPr>
@@ -5751,17 +5744,29 @@
               </p:nvSpPr>
               <p:spPr>
                 <a:xfrm>
-                  <a:off x="4031500" y="2460708"/>
-                  <a:ext cx="435368" cy="430089"/>
+                  <a:off x="4079958" y="2506969"/>
+                  <a:ext cx="336786" cy="332701"/>
                 </a:xfrm>
                 <a:prstGeom prst="ellipse">
                   <a:avLst/>
                 </a:prstGeom>
-                <a:solidFill>
-                  <a:srgbClr val="77B0E6">
-                    <a:alpha val="67000"/>
-                  </a:srgbClr>
-                </a:solidFill>
+                <a:gradFill>
+                  <a:gsLst>
+                    <a:gs pos="88000">
+                      <a:srgbClr val="608DBC">
+                        <a:lumMod val="100000"/>
+                      </a:srgbClr>
+                    </a:gs>
+                    <a:gs pos="55000">
+                      <a:srgbClr val="83B7E8">
+                        <a:lumMod val="96000"/>
+                      </a:srgbClr>
+                    </a:gs>
+                  </a:gsLst>
+                  <a:path path="circle">
+                    <a:fillToRect l="50000" t="50000" r="50000" b="50000"/>
+                  </a:path>
+                </a:gradFill>
                 <a:ln>
                   <a:noFill/>
                 </a:ln>

</xml_diff>